<commit_message>
Add install slide and slide-by-slide topics guide
- New "Installs in one line" slide right after the Herdr intro, with
  brew/curl install, launch, and the agent integration hook
- Rebuild Keynote and PowerPoint decks (now 25 slides)
- Add topics.md walking the deck's topics with links, commands,
  prompts, and screenshot call-outs

Co-Authored-By: Claude Opus 5.5 <noreply@anthropic.com>
</commit_message>
<xml_diff>
--- a/presentation/herding-agents.pptx
+++ b/presentation/herding-agents.pptx
@@ -29,6 +29,7 @@
     <p:sldId id="277" r:id="rId29"/>
     <p:sldId id="278" r:id="rId30"/>
     <p:sldId id="279" r:id="rId31"/>
+    <p:sldId id="280" r:id="rId32"/>
   </p:sldIdLst>
   <p:sldSz cx="12191695" cy="6858000" type="screen4x3"/>
   <p:notesSz cx="6858000" cy="9144000"/>
@@ -623,19 +624,41 @@
           <a:lstStyle/>
           <a:p>
             <a:r>
-              <a:t>Domain-modeling tab in ledger-service. One agent column on the left. On the right, the domain notes and the entity code on top, git history below.</a:t>
+              <a:t>Rule two. Tabs aren't 'more room.' Tabs are modes, and each one is a different verb.</a:t>
             </a:r>
           </a:p>
           <a:p/>
           <a:p>
             <a:r>
-              <a:t>The agent was asked to describe a Posting aggregate using only Account, Entry, Journal, Posting, never 'transaction', and not to write code. We'll zoom in on the result later.</a:t>
+              <a:t>- domain-modeling: the agent thinks and doesn't type. Plan mode. Glossary and domain notes open beside it.</a:t>
+            </a:r>
+          </a:p>
+          <a:p>
+            <a:r>
+              <a:t>- implementation: the agent changes code inside an explicit scope, after an approved plan.</a:t>
+            </a:r>
+          </a:p>
+          <a:p>
+            <a:r>
+              <a:t>- pr-reviews: the agent reads the diff and reports findings. It doesn't fix.</a:t>
             </a:r>
           </a:p>
           <a:p/>
           <a:p>
             <a:r>
-              <a:t>The reference panes aren't decoration. They're there so I can check the agent's vocabulary against the agreed vocabulary without switching anything.</a:t>
+              <a:t>What I'm designing against is verb drift: a reviewer that slides into rewriting the module. The tab is the line it has to cross, drawn on screen.</a:t>
+            </a:r>
+          </a:p>
+          <a:p/>
+          <a:p>
+            <a:r>
+              <a:t>It also switches my own hat. When I land on a tab called pr-reviews, I'm in review mode before I read a word.</a:t>
+            </a:r>
+          </a:p>
+          <a:p/>
+          <a:p>
+            <a:r>
+              <a:t>Ref: Ask, Plan, Confirm: https://compositecode.blog/2026/08/20/plan-then-build/</a:t>
             </a:r>
           </a:p>
         </p:txBody>
@@ -705,24 +728,19 @@
           <a:lstStyle/>
           <a:p>
             <a:r>
-              <a:t>Implementation tab. Two agents, each fenced to a different slice of the code: one planning tests for Posting.Validate, one planning a CLI entrypoint in cmd/main.go only.</a:t>
+              <a:t>Domain-modeling tab in ledger-service. One agent column on the left. On the right, the domain notes and the entity code on top, git history below.</a:t>
             </a:r>
           </a:p>
           <a:p/>
           <a:p>
             <a:r>
-              <a:t>On the right, a diffstat over a shell, so I can see what actually changed, not what the agent says changed.</a:t>
+              <a:t>The agent was asked to describe a Posting aggregate using only Account, Entry, Journal, Posting, never 'transaction', and not to write code. We'll zoom in on the result later.</a:t>
             </a:r>
           </a:p>
           <a:p/>
           <a:p>
             <a:r>
-              <a:t>In real work, parallel implementation agents on one repo each get their own worktree and branch.</a:t>
-            </a:r>
-          </a:p>
-          <a:p>
-            <a:r>
-              <a:t>Ref: https://compositecode.blog/2026/08/19/worktrees/</a:t>
+              <a:t>The reference panes aren't decoration. They're there so I can check the agent's vocabulary against the agreed vocabulary without switching anything.</a:t>
             </a:r>
           </a:p>
         </p:txBody>
@@ -792,19 +810,24 @@
           <a:lstStyle/>
           <a:p>
             <a:r>
-              <a:t>PR-reviews tab. Reviewer on the left, raw diff on the right.</a:t>
+              <a:t>Implementation tab. Two agents, each fenced to a different slice of the code: one planning tests for Posting.Validate, one planning a CLI entrypoint in cmd/main.go only.</a:t>
             </a:r>
           </a:p>
           <a:p/>
           <a:p>
             <a:r>
-              <a:t>Every file:line the reviewer cites can be checked by moving my eyes and nothing else. Trust, but keep the evidence in the same field of view.</a:t>
+              <a:t>On the right, a diffstat over a shell, so I can see what actually changed, not what the agent says changed.</a:t>
             </a:r>
           </a:p>
           <a:p/>
           <a:p>
             <a:r>
-              <a:t>The reviewer is read-only. If I want a fix, that's a new, scoped task in the implementation tab.</a:t>
+              <a:t>In real work, parallel implementation agents on one repo each get their own worktree and branch.</a:t>
+            </a:r>
+          </a:p>
+          <a:p>
+            <a:r>
+              <a:t>Ref: https://compositecode.blog/2026/08/19/worktrees/</a:t>
             </a:r>
           </a:p>
         </p:txBody>
@@ -874,36 +897,19 @@
           <a:lstStyle/>
           <a:p>
             <a:r>
-              <a:t>Rule three, about panes.</a:t>
+              <a:t>PR-reviews tab. Reviewer on the left, raw diff on the right.</a:t>
             </a:r>
           </a:p>
           <a:p/>
           <a:p>
             <a:r>
-              <a:t>Agents produce long, structured output (plans, findings, tables), so they get full-height vertical splits, side by side: prefix v.</a:t>
+              <a:t>Every file:line the reviewer cites can be checked by moving my eyes and nothing else. Trust, but keep the evidence in the same field of view.</a:t>
             </a:r>
           </a:p>
           <a:p/>
           <a:p>
             <a:r>
-              <a:t>Shells, test runners, git log, and diffstats are glanceable, so they get short horizontal splits stacked in a utility column: prefix minus.</a:t>
-            </a:r>
-          </a:p>
-          <a:p/>
-          <a:p>
-            <a:r>
-              <a:t>One pane is one agent, one context window, one job. When the job is done, end the conversation. New job, new agent, clean context.</a:t>
-            </a:r>
-          </a:p>
-          <a:p/>
-          <a:p>
-            <a:r>
-              <a:t>Keys (prefix is ctrl+b): v split vertical, - split horizontal, h/j/k/l move, z zoom, r resize, c new tab, shift+n new space, w space picker, b sidebar, q detach, ? help.</a:t>
-            </a:r>
-          </a:p>
-          <a:p>
-            <a:r>
-              <a:t>Ref: https://herdr.dev/docs/configuration/</a:t>
+              <a:t>The reviewer is read-only. If I want a fix, that's a new, scoped task in the implementation tab.</a:t>
             </a:r>
           </a:p>
         </p:txBody>
@@ -973,19 +979,36 @@
           <a:lstStyle/>
           <a:p>
             <a:r>
-              <a:t>The cheat code. A 5120×1440 ultrawide: two 2560×1440 screens fused, no bezel in the middle.</a:t>
+              <a:t>Rule three, about panes.</a:t>
             </a:r>
           </a:p>
           <a:p/>
           <a:p>
             <a:r>
-              <a:t>At normal terminal font sizes that's three or four full-height agent columns, plus a utility column, plus the sidebar, all visible at once.</a:t>
+              <a:t>Agents produce long, structured output (plans, findings, tables), so they get full-height vertical splits, side by side: prefix v.</a:t>
             </a:r>
           </a:p>
           <a:p/>
           <a:p>
             <a:r>
-              <a:t>The next two slides show the same tab at both widths.</a:t>
+              <a:t>Shells, test runners, git log, and diffstats are glanceable, so they get short horizontal splits stacked in a utility column: prefix minus.</a:t>
+            </a:r>
+          </a:p>
+          <a:p/>
+          <a:p>
+            <a:r>
+              <a:t>One pane is one agent, one context window, one job. When the job is done, end the conversation. New job, new agent, clean context.</a:t>
+            </a:r>
+          </a:p>
+          <a:p/>
+          <a:p>
+            <a:r>
+              <a:t>Keys (prefix is ctrl+b): v split vertical, - split horizontal, h/j/k/l move, z zoom, r resize, c new tab, shift+n new space, w space picker, b sidebar, q detach, ? help.</a:t>
+            </a:r>
+          </a:p>
+          <a:p>
+            <a:r>
+              <a:t>Ref: https://herdr.dev/docs/configuration/</a:t>
             </a:r>
           </a:p>
         </p:txBody>
@@ -1055,13 +1078,19 @@
           <a:lstStyle/>
           <a:p>
             <a:r>
-              <a:t>The same implementation tab at 2560×1440, a normal 16:9 screen.</a:t>
+              <a:t>The cheat code. A 5120×1440 ultrawide: two 2560×1440 screens fused, no bezel in the middle.</a:t>
             </a:r>
           </a:p>
           <a:p/>
           <a:p>
             <a:r>
-              <a:t>Workable. Tight. Two agents and a utility column, and you're already making choices. Add a third agent and you're zooming panes in and out all day.</a:t>
+              <a:t>At normal terminal font sizes that's three or four full-height agent columns, plus a utility column, plus the sidebar, all visible at once.</a:t>
+            </a:r>
+          </a:p>
+          <a:p/>
+          <a:p>
+            <a:r>
+              <a:t>The next two slides show the same tab at both widths.</a:t>
             </a:r>
           </a:p>
         </p:txBody>
@@ -1131,19 +1160,13 @@
           <a:lstStyle/>
           <a:p>
             <a:r>
-              <a:t>Same tab on the full ultrawide.</a:t>
+              <a:t>The same implementation tab at 2560×1440, a normal 16:9 screen.</a:t>
             </a:r>
           </a:p>
           <a:p/>
           <a:p>
             <a:r>
-              <a:t>The difference isn't 'more stuff.' It's that nothing is hidden. A blocked agent costs you time silently. Herdr's sidebar tells you THAT something is blocked; having it physically on screen tells you WHY, in peripheral vision, without moving.</a:t>
-            </a:r>
-          </a:p>
-          <a:p/>
-          <a:p>
-            <a:r>
-              <a:t>The less effort it takes to notice, the shorter the stall.</a:t>
+              <a:t>Workable. Tight. Two agents and a utility column, and you're already making choices. Add a third agent and you're zooming panes in and out all day.</a:t>
             </a:r>
           </a:p>
         </p:txBody>
@@ -1213,35 +1236,19 @@
           <a:lstStyle/>
           <a:p>
             <a:r>
-              <a:t>Turn. Everything so far is plumbing. The water is language.</a:t>
+              <a:t>Same tab on the full ultrawide.</a:t>
             </a:r>
           </a:p>
           <a:p/>
           <a:p>
             <a:r>
-              <a:t>A vague word in a chat gets you a vague paragraph. A vague word in an agent prompt gets you a nine-file diff.</a:t>
+              <a:t>The difference isn't 'more stuff.' It's that nothing is hidden. A blocked agent costs you time silently. Herdr's sidebar tells you THAT something is blocked; having it physically on screen tells you WHY, in peripheral vision, without moving.</a:t>
             </a:r>
           </a:p>
           <a:p/>
           <a:p>
             <a:r>
-              <a:t>I've written about this before:</a:t>
-            </a:r>
-          </a:p>
-          <a:p>
-            <a:r>
-              <a:t>- Precision in Words, Precision in Code: https://compositecode.blog/2024/12/09/precision-in-words-precision-in-code-the-power-of-writing-in-modern-development/</a:t>
-            </a:r>
-          </a:p>
-          <a:p>
-            <a:r>
-              <a:t>- AI Prompt Engineering: Mastering Language Constructs: https://compositecode.blog/2025/02/25/ai-prompt-engineering-mastering-language-constructs/</a:t>
-            </a:r>
-          </a:p>
-          <a:p/>
-          <a:p>
-            <a:r>
-              <a:t>The next three slides are real prompts and real responses from the demo.</a:t>
+              <a:t>The less effort it takes to notice, the shorter the stall.</a:t>
             </a:r>
           </a:p>
         </p:txBody>
@@ -1311,41 +1318,35 @@
           <a:lstStyle/>
           <a:p>
             <a:r>
-              <a:t>Prompt: "Read docs/domain.md and internal/ledger/entry.go. Using only the domain terms Account, Entry, Journal, and Posting (never 'transaction'), describe a Posting aggregate: its invariants, what it owns, and what it must reject. Do not write code."</a:t>
+              <a:t>Turn. Everything so far is plumbing. The water is language.</a:t>
             </a:r>
           </a:p>
           <a:p/>
           <a:p>
             <a:r>
-              <a:t>Accurate language means the same word means the same thing every time: docs, code, prompt, review. That's ubiquitous language from DDD. Agents need it more than people do, because they fill every gap with the statistically likely meaning, which is rarely yours.</a:t>
+              <a:t>A vague word in a chat gets you a vague paragraph. A vague word in an agent prompt gets you a nine-file diff.</a:t>
             </a:r>
           </a:p>
           <a:p/>
           <a:p>
             <a:r>
-              <a:t>'Transaction' is banned because in a ledger it's overloaded: a database transaction, a business event, a statement line.</a:t>
+              <a:t>I've written about this before:</a:t>
+            </a:r>
+          </a:p>
+          <a:p>
+            <a:r>
+              <a:t>- Precision in Words, Precision in Code: https://compositecode.blog/2024/12/09/precision-in-words-precision-in-code-the-power-of-writing-in-modern-development/</a:t>
+            </a:r>
+          </a:p>
+          <a:p>
+            <a:r>
+              <a:t>- AI Prompt Engineering: Mastering Language Constructs: https://compositecode.blog/2025/02/25/ai-prompt-engineering-mastering-language-constructs/</a:t>
             </a:r>
           </a:p>
           <a:p/>
           <a:p>
             <a:r>
-              <a:t>Result: the model stays inside the vocabulary AND marks which rules it inferred versus which came from the repo.</a:t>
-            </a:r>
-          </a:p>
-          <a:p/>
-          <a:p>
-            <a:r>
-              <a:t>Refs:</a:t>
-            </a:r>
-          </a:p>
-          <a:p>
-            <a:r>
-              <a:t>- Notes repos, where the glossary lives: https://compositecode.blog/2026/09/25/notes-repos-as-shared-project-context/</a:t>
-            </a:r>
-          </a:p>
-          <a:p>
-            <a:r>
-              <a:t>- Fowler, Ubiquitous Language: https://martinfowler.com/bliki/UbiquitousLanguage.html</a:t>
+              <a:t>The next three slides are real prompts and real responses from the demo.</a:t>
             </a:r>
           </a:p>
         </p:txBody>
@@ -1415,31 +1416,41 @@
           <a:lstStyle/>
           <a:p>
             <a:r>
-              <a:t>Prompt: "Scope: cmd/main.go only. Plan a minimal CLI entrypoint that loads a Journal from a JSON file and prints the balance per Account. Do not touch internal/ledger. Keep the planned diff under 50 lines."</a:t>
+              <a:t>Prompt: "Read docs/domain.md and internal/ledger/entry.go. Using only the domain terms Account, Entry, Journal, and Posting (never 'transaction'), describe a Posting aggregate: its invariants, what it owns, and what it must reject. Do not write code."</a:t>
             </a:r>
           </a:p>
           <a:p/>
           <a:p>
             <a:r>
-              <a:t>Scope is the first word. Positive fence, negative fence, size as a number.</a:t>
+              <a:t>Accurate language means the same word means the same thing every time: docs, code, prompt, review. That's ubiquitous language from DDD. Agents need it more than people do, because they fill every gap with the statistically likely meaning, which is rarely yours.</a:t>
             </a:r>
           </a:p>
           <a:p/>
           <a:p>
             <a:r>
-              <a:t>The repo had no go.mod, so staying in scope needed a decision. An unfenced agent adds a module, rewires imports, and stubs types in the package I fenced off. This one stopped, went blocked, recommended the in-scope option, and called the other option out of scope.</a:t>
+              <a:t>'Transaction' is banned because in a ledger it's overloaded: a database transaction, a business event, a statement line.</a:t>
             </a:r>
           </a:p>
           <a:p/>
           <a:p>
             <a:r>
-              <a:t>Herdr flagged it. The ultrawide showed it. One keystroke to answer.</a:t>
+              <a:t>Result: the model stays inside the vocabulary AND marks which rules it inferred versus which came from the repo.</a:t>
             </a:r>
           </a:p>
           <a:p/>
           <a:p>
             <a:r>
-              <a:t>Ref: Hurting or Helping Devs? (scope and diff limits): https://compositecode.blog/2026/04/15/hurting-or-helping-devs/</a:t>
+              <a:t>Refs:</a:t>
+            </a:r>
+          </a:p>
+          <a:p>
+            <a:r>
+              <a:t>- Notes repos, where the glossary lives: https://compositecode.blog/2026/09/25/notes-repos-as-shared-project-context/</a:t>
+            </a:r>
+          </a:p>
+          <a:p>
+            <a:r>
+              <a:t>- Fowler, Ubiquitous Language: https://martinfowler.com/bliki/UbiquitousLanguage.html</a:t>
             </a:r>
           </a:p>
         </p:txBody>
@@ -1591,31 +1602,31 @@
           <a:lstStyle/>
           <a:p>
             <a:r>
-              <a:t>Prompt: "Review the diff main...feature/posting-aggregate. Classify every change as additive, mutative, or destructive. Flag any naming that drifts from docs/domain.md. Report findings as a numbered list with file:line. Do not propose rewrites outside the diff."</a:t>
+              <a:t>Prompt: "Scope: cmd/main.go only. Plan a minimal CLI entrypoint that loads a Journal from a JSON file and prints the balance per Account. Do not touch internal/ledger. Keep the planned diff under 50 lines."</a:t>
             </a:r>
           </a:p>
           <a:p/>
           <a:p>
             <a:r>
-              <a:t>Precise verbs: plan, implement, review, and fix are different jobs. Review doesn't mean fix.</a:t>
+              <a:t>Scope is the first word. Positive fence, negative fence, size as a number.</a:t>
             </a:r>
           </a:p>
           <a:p/>
           <a:p>
             <a:r>
-              <a:t>Specify the output shape (numbered, file:line) so it can be checked against the diff pane next door.</a:t>
+              <a:t>The repo had no go.mod, so staying in scope needed a decision. An unfenced agent adds a module, rewires imports, and stubs types in the package I fenced off. This one stopped, went blocked, recommended the in-scope option, and called the other option out of scope.</a:t>
             </a:r>
           </a:p>
           <a:p/>
           <a:p>
             <a:r>
-              <a:t>Because the question was precise, the reviewer had attention to spare. It flagged that any Direction other than exactly "debit" counts as a credit, and that an empty Posting validates as balanced. That's behavioral drift, the quiet kind.</a:t>
+              <a:t>Herdr flagged it. The ultrawide showed it. One keystroke to answer.</a:t>
             </a:r>
           </a:p>
           <a:p/>
           <a:p>
             <a:r>
-              <a:t>Ref: Additive vs. Mutative vs. Destructive Code Changes: https://compositecode.blog/2026/02/12/additive-vs-mutative-vs-destructive-code-changes-and-why-ai-agents-love-the-wrong-one-at-213am/</a:t>
+              <a:t>Ref: Hurting or Helping Devs? (scope and diff limits): https://compositecode.blog/2026/04/15/hurting-or-helping-devs/</a:t>
             </a:r>
           </a:p>
         </p:txBody>
@@ -1685,60 +1696,31 @@
           <a:lstStyle/>
           <a:p>
             <a:r>
-              <a:t>The template I use for Claude Code, Codex, and Cursor alike:</a:t>
+              <a:t>Prompt: "Review the diff main...feature/posting-aggregate. Classify every change as additive, mutative, or destructive. Flag any naming that drifts from docs/domain.md. Report findings as a numbered list with file:line. Do not propose rewrites outside the diff."</a:t>
             </a:r>
           </a:p>
           <a:p/>
           <a:p>
             <a:r>
-              <a:t>Scope: &lt;paths&gt; only. Do not touch: &lt;paths&gt;.</a:t>
-            </a:r>
-          </a:p>
-          <a:p>
-            <a:r>
-              <a:t>Context: Read &lt;files / glossary / plan&gt;. Use the terms &lt;A, B, C&gt;; never &lt;overloaded term&gt;.</a:t>
-            </a:r>
-          </a:p>
-          <a:p>
-            <a:r>
-              <a:t>Task (plan | implement | review): &lt;one sentence, one job&gt;.</a:t>
-            </a:r>
-          </a:p>
-          <a:p>
-            <a:r>
-              <a:t>Constraints: additive only | under N lines | no new dependencies | tests first.</a:t>
-            </a:r>
-          </a:p>
-          <a:p>
-            <a:r>
-              <a:t>Output: numbered list | file:line | severity first | test names first.</a:t>
-            </a:r>
-          </a:p>
-          <a:p>
-            <a:r>
-              <a:t>If anything above is ambiguous or blocks you, stop and ask.</a:t>
+              <a:t>Precise verbs: plan, implement, review, and fix are different jobs. Review doesn't mean fix.</a:t>
             </a:r>
           </a:p>
           <a:p/>
           <a:p>
             <a:r>
-              <a:t>The last line matters most. It turns 'the agent is stuck' from a silent failure into a blocked state, and Herdr turns that into a dot I can see from across the room.</a:t>
+              <a:t>Specify the output shape (numbered, file:line) so it can be checked against the diff pane next door.</a:t>
             </a:r>
           </a:p>
           <a:p/>
           <a:p>
             <a:r>
-              <a:t>Front-load context instead of looping for it:</a:t>
-            </a:r>
-          </a:p>
-          <a:p>
-            <a:r>
-              <a:t>- Loop Engineering post: https://compositecode.blog/2026/07/15/loop-engineering-is-mostly-just-broken-sdlc-wearing-a-costume/</a:t>
-            </a:r>
-          </a:p>
-          <a:p>
-            <a:r>
-              <a:t>- Agent-ready environments: https://compositecode.blog/2026/09/24/agent-ready-local-environments-and-mcp/</a:t>
+              <a:t>Because the question was precise, the reviewer had attention to spare. It flagged that any Direction other than exactly "debit" counts as a credit, and that an empty Posting validates as balanced. That's behavioral drift, the quiet kind.</a:t>
+            </a:r>
+          </a:p>
+          <a:p/>
+          <a:p>
+            <a:r>
+              <a:t>Ref: Additive vs. Mutative vs. Destructive Code Changes: https://compositecode.blog/2026/02/12/additive-vs-mutative-vs-destructive-code-changes-and-why-ai-agents-love-the-wrong-one-at-213am/</a:t>
             </a:r>
           </a:p>
         </p:txBody>
@@ -1808,40 +1790,60 @@
           <a:lstStyle/>
           <a:p>
             <a:r>
-              <a:t>The gate. No edits until the agent has asked what it needs to ask, shown a plan, and gotten a yes. Approval is scoped to the plan that was approved; if the work grows past it, the agent re-plans.</a:t>
+              <a:t>The template I use for Claude Code, Codex, and Cursor alike:</a:t>
             </a:r>
           </a:p>
           <a:p/>
           <a:p>
             <a:r>
-              <a:t>Backed by tooling: agents start in plan mode (claude --permission-mode plan; Codex and Cursor have their own read-only and ask-first modes).</a:t>
+              <a:t>Scope: &lt;paths&gt; only. Do not touch: &lt;paths&gt;.</a:t>
+            </a:r>
+          </a:p>
+          <a:p>
+            <a:r>
+              <a:t>Context: Read &lt;files / glossary / plan&gt;. Use the terms &lt;A, B, C&gt;; never &lt;overloaded term&gt;.</a:t>
+            </a:r>
+          </a:p>
+          <a:p>
+            <a:r>
+              <a:t>Task (plan | implement | review): &lt;one sentence, one job&gt;.</a:t>
+            </a:r>
+          </a:p>
+          <a:p>
+            <a:r>
+              <a:t>Constraints: additive only | under N lines | no new dependencies | tests first.</a:t>
+            </a:r>
+          </a:p>
+          <a:p>
+            <a:r>
+              <a:t>Output: numbered list | file:line | severity first | test names first.</a:t>
+            </a:r>
+          </a:p>
+          <a:p>
+            <a:r>
+              <a:t>If anything above is ambiguous or blocks you, stop and ask.</a:t>
             </a:r>
           </a:p>
           <a:p/>
           <a:p>
             <a:r>
-              <a:t>My side of the loop:</a:t>
-            </a:r>
-          </a:p>
-          <a:p>
-            <a:r>
-              <a:t>- Blocked: answer in place. If the answer is a decision, write it into the notes repo.</a:t>
-            </a:r>
-          </a:p>
-          <a:p>
-            <a:r>
-              <a:t>- Done: check the output against the evidence pane. Approve, correct, or open a scoped fix in the implementation tab.</a:t>
-            </a:r>
-          </a:p>
-          <a:p>
-            <a:r>
-              <a:t>- Job finished: end that conversation.</a:t>
+              <a:t>The last line matters most. It turns 'the agent is stuck' from a silent failure into a blocked state, and Herdr turns that into a dot I can see from across the room.</a:t>
             </a:r>
           </a:p>
           <a:p/>
           <a:p>
             <a:r>
-              <a:t>Ref: https://compositecode.blog/2026/08/20/plan-then-build/</a:t>
+              <a:t>Front-load context instead of looping for it:</a:t>
+            </a:r>
+          </a:p>
+          <a:p>
+            <a:r>
+              <a:t>- Loop Engineering post: https://compositecode.blog/2026/07/15/loop-engineering-is-mostly-just-broken-sdlc-wearing-a-costume/</a:t>
+            </a:r>
+          </a:p>
+          <a:p>
+            <a:r>
+              <a:t>- Agent-ready environments: https://compositecode.blog/2026/09/24/agent-ready-local-environments-and-mcp/</a:t>
             </a:r>
           </a:p>
         </p:txBody>
@@ -1911,55 +1913,40 @@
           <a:lstStyle/>
           <a:p>
             <a:r>
-              <a:t>Getting started takes three lines: install, launch, open help.</a:t>
+              <a:t>The gate. No edits until the agent has asked what it needs to ask, shown a plan, and gotten a yes. Approval is scoped to the plan that was approved; if the work grows past it, the agent re-plans.</a:t>
             </a:r>
           </a:p>
           <a:p/>
           <a:p>
             <a:r>
-              <a:t>Then:</a:t>
-            </a:r>
-          </a:p>
-          <a:p>
-            <a:r>
-              <a:t>- Make a space per folder you're working in (prefix shift+n, or herdr workspace create --cwd &lt;dir&gt; --label &lt;name&gt;).</a:t>
-            </a:r>
-          </a:p>
-          <a:p>
-            <a:r>
-              <a:t>- Name tabs for the kind of work (prefix shift+t).</a:t>
-            </a:r>
-          </a:p>
-          <a:p>
-            <a:r>
-              <a:t>- Agents tall (prefix v), shells short (prefix -).</a:t>
-            </a:r>
-          </a:p>
-          <a:p>
-            <a:r>
-              <a:t>- herdr integration install claude (and codex, etc.) for accurate state dots.</a:t>
+              <a:t>Backed by tooling: agents start in plan mode (claude --permission-mode plan; Codex and Cursor have their own read-only and ask-first modes).</a:t>
             </a:r>
           </a:p>
           <a:p/>
           <a:p>
             <a:r>
-              <a:t>Worst case, you've got a nice tmux. Best case, you stop finding agents that have been patiently blocked since lunch.</a:t>
+              <a:t>My side of the loop:</a:t>
+            </a:r>
+          </a:p>
+          <a:p>
+            <a:r>
+              <a:t>- Blocked: answer in place. If the answer is a decision, write it into the notes repo.</a:t>
+            </a:r>
+          </a:p>
+          <a:p>
+            <a:r>
+              <a:t>- Done: check the output against the evidence pane. Approve, correct, or open a scoped fix in the implementation tab.</a:t>
+            </a:r>
+          </a:p>
+          <a:p>
+            <a:r>
+              <a:t>- Job finished: end that conversation.</a:t>
             </a:r>
           </a:p>
           <a:p/>
           <a:p>
             <a:r>
-              <a:t>Refs:</a:t>
-            </a:r>
-          </a:p>
-          <a:p>
-            <a:r>
-              <a:t>- https://herdr.dev/docs/quick-start/</a:t>
-            </a:r>
-          </a:p>
-          <a:p>
-            <a:r>
-              <a:t>- https://herdr.dev/docs/configuration/</a:t>
+              <a:t>Ref: https://compositecode.blog/2026/08/20/plan-then-build/</a:t>
             </a:r>
           </a:p>
         </p:txBody>
@@ -2029,6 +2016,124 @@
           <a:lstStyle/>
           <a:p>
             <a:r>
+              <a:t>Getting started takes three lines: install, launch, open help.</a:t>
+            </a:r>
+          </a:p>
+          <a:p/>
+          <a:p>
+            <a:r>
+              <a:t>Then:</a:t>
+            </a:r>
+          </a:p>
+          <a:p>
+            <a:r>
+              <a:t>- Make a space per folder you're working in (prefix shift+n, or herdr workspace create --cwd &lt;dir&gt; --label &lt;name&gt;).</a:t>
+            </a:r>
+          </a:p>
+          <a:p>
+            <a:r>
+              <a:t>- Name tabs for the kind of work (prefix shift+t).</a:t>
+            </a:r>
+          </a:p>
+          <a:p>
+            <a:r>
+              <a:t>- Agents tall (prefix v), shells short (prefix -).</a:t>
+            </a:r>
+          </a:p>
+          <a:p>
+            <a:r>
+              <a:t>- herdr integration install claude (and codex, etc.) for accurate state dots.</a:t>
+            </a:r>
+          </a:p>
+          <a:p/>
+          <a:p>
+            <a:r>
+              <a:t>Worst case, you've got a nice tmux. Best case, you stop finding agents that have been patiently blocked since lunch.</a:t>
+            </a:r>
+          </a:p>
+          <a:p/>
+          <a:p>
+            <a:r>
+              <a:t>Refs:</a:t>
+            </a:r>
+          </a:p>
+          <a:p>
+            <a:r>
+              <a:t>- https://herdr.dev/docs/quick-start/</a:t>
+            </a:r>
+          </a:p>
+          <a:p>
+            <a:r>
+              <a:t>- https://herdr.dev/docs/configuration/</a:t>
+            </a:r>
+          </a:p>
+        </p:txBody>
+      </p:sp>
+      <p:sp>
+        <p:nvSpPr>
+          <p:cNvPr id="4" name="Slide Number Placeholder 3"/>
+          <p:cNvSpPr>
+            <a:spLocks noGrp="1"/>
+          </p:cNvSpPr>
+          <p:nvPr>
+            <p:ph type="sldNum" idx="5" sz="quarter"/>
+          </p:nvPr>
+        </p:nvSpPr>
+        <p:spPr/>
+      </p:sp>
+    </p:spTree>
+  </p:cSld>
+  <p:clrMapOvr>
+    <a:masterClrMapping/>
+  </p:clrMapOvr>
+</p:notes>
+</file>
+
+<file path=ppt/notesSlides/notesSlide25.xml><?xml version="1.0" encoding="utf-8"?>
+<p:notes xmlns:a="http://schemas.openxmlformats.org/drawingml/2006/main" xmlns:p="http://schemas.openxmlformats.org/presentationml/2006/main" xmlns:r="http://schemas.openxmlformats.org/officeDocument/2006/relationships">
+  <p:cSld>
+    <p:spTree>
+      <p:nvGrpSpPr>
+        <p:cNvPr id="1" name=""/>
+        <p:cNvGrpSpPr/>
+        <p:nvPr/>
+      </p:nvGrpSpPr>
+      <p:grpSpPr>
+        <a:xfrm>
+          <a:off x="0" y="0"/>
+          <a:ext cx="0" cy="0"/>
+          <a:chOff x="0" y="0"/>
+          <a:chExt cx="0" cy="0"/>
+        </a:xfrm>
+      </p:grpSpPr>
+      <p:sp>
+        <p:nvSpPr>
+          <p:cNvPr id="2" name="Slide Image Placeholder 1"/>
+          <p:cNvSpPr>
+            <a:spLocks noGrp="1"/>
+          </p:cNvSpPr>
+          <p:nvPr>
+            <p:ph type="sldImg" idx="2"/>
+          </p:nvPr>
+        </p:nvSpPr>
+        <p:spPr/>
+      </p:sp>
+      <p:sp>
+        <p:nvSpPr>
+          <p:cNvPr id="3" name="Notes Placeholder 2"/>
+          <p:cNvSpPr>
+            <a:spLocks noGrp="1"/>
+          </p:cNvSpPr>
+          <p:nvPr>
+            <p:ph type="body" idx="3" sz="quarter"/>
+          </p:nvPr>
+        </p:nvSpPr>
+        <p:spPr/>
+        <p:txBody>
+          <a:bodyPr/>
+          <a:lstStyle/>
+          <a:p>
+            <a:r>
               <a:t>Draw the boundaries on screen. Draw them again in words. Then let the agents work.</a:t>
             </a:r>
           </a:p>
@@ -2261,7 +2366,7 @@
           <a:p/>
           <a:p>
             <a:r>
-              <a:t>Install: brew install herdr, or curl -fsSL https://herdr.dev/install.sh | sh</a:t>
+              <a:t>Installing it is the next slide, because it's that short.</a:t>
             </a:r>
           </a:p>
           <a:p/>
@@ -2352,40 +2457,50 @@
           <a:lstStyle/>
           <a:p>
             <a:r>
-              <a:t>The four nouns, straight from the Herdr concepts page.</a:t>
+              <a:t>Getting Herdr running is about as short as it gets, which matters, because the barrier to trying a new tool is usually the setup, not the tool.</a:t>
             </a:r>
           </a:p>
           <a:p/>
           <a:p>
             <a:r>
-              <a:t>- Session: a persistent server namespace. `herdr` attaches to the default; `herdr --session name` gives you an isolated one.</a:t>
-            </a:r>
-          </a:p>
-          <a:p>
-            <a:r>
-              <a:t>- Workspace (the sidebar calls them spaces): "the top-level project container. Use one workspace per repo, task, or investigation."</a:t>
-            </a:r>
-          </a:p>
-          <a:p>
-            <a:r>
-              <a:t>- Tab: "a layout inside a workspace."</a:t>
-            </a:r>
-          </a:p>
-          <a:p>
-            <a:r>
-              <a:t>- Pane: "a real terminal."</a:t>
+              <a:t>1. brew install herdr on macOS, or the one-line install script anywhere else. It's a single Rust binary: no runtime, no Electron, nothing else to install alongside it.</a:t>
+            </a:r>
+          </a:p>
+          <a:p>
+            <a:r>
+              <a:t>2. Run herdr. It starts its background server and attaches you to the default session, inside whatever terminal you already use (iTerm, Ghostty, WezTerm, kitty, Alacritty, even tmux). No config file is required to start.</a:t>
+            </a:r>
+          </a:p>
+          <a:p>
+            <a:r>
+              <a:t>3. Optional but worth it: herdr integration install claude (or codex, copilot, opencode…) adds a small hook so each agent reports its own state instead of Herdr inferring it from the screen. herdr integration status shows what's wired.</a:t>
             </a:r>
           </a:p>
           <a:p/>
           <a:p>
             <a:r>
-              <a:t>If you know tmux, you already have most of this model. The difference is what Herdr knows about what's running in each pane.</a:t>
+              <a:t>From zero to a working agent workspace in two or three commands. Everything after this in the talk is how I lay it out and how I talk to the agents, not more setup.</a:t>
             </a:r>
           </a:p>
           <a:p/>
           <a:p>
             <a:r>
-              <a:t>Ref: https://herdr.dev/docs/concepts/</a:t>
+              <a:t>Refs:</a:t>
+            </a:r>
+          </a:p>
+          <a:p>
+            <a:r>
+              <a:t>- https://herdr.dev/docs/install/</a:t>
+            </a:r>
+          </a:p>
+          <a:p>
+            <a:r>
+              <a:t>- https://herdr.dev/docs/quick-start/</a:t>
+            </a:r>
+          </a:p>
+          <a:p>
+            <a:r>
+              <a:t>- https://herdr.dev/docs/agents/</a:t>
             </a:r>
           </a:p>
         </p:txBody>
@@ -2455,61 +2570,40 @@
           <a:lstStyle/>
           <a:p>
             <a:r>
-              <a:t>The sidebar. Spaces up top, every agent across every space listed below with a state dot.</a:t>
+              <a:t>The four nouns, straight from the Herdr concepts page.</a:t>
             </a:r>
           </a:p>
           <a:p/>
           <a:p>
             <a:r>
-              <a:t>- Blocked: needs input, approval, or a decision. This is the one you care about.</a:t>
-            </a:r>
-          </a:p>
-          <a:p>
-            <a:r>
-              <a:t>- Working: chewing.</a:t>
-            </a:r>
-          </a:p>
-          <a:p>
-            <a:r>
-              <a:t>- Done: finished, and you haven't looked yet.</a:t>
-            </a:r>
-          </a:p>
-          <a:p>
-            <a:r>
-              <a:t>- Idle: finished, and you have looked.</a:t>
-            </a:r>
-          </a:p>
-          <a:p>
-            <a:r>
-              <a:t>- Unknown: Herdr can't tell, usually a plain shell.</a:t>
+              <a:t>- Session: a persistent server namespace. `herdr` attaches to the default; `herdr --session name` gives you an isolated one.</a:t>
+            </a:r>
+          </a:p>
+          <a:p>
+            <a:r>
+              <a:t>- Workspace (the sidebar calls them spaces): "the top-level project container. Use one workspace per repo, task, or investigation."</a:t>
+            </a:r>
+          </a:p>
+          <a:p>
+            <a:r>
+              <a:t>- Tab: "a layout inside a workspace."</a:t>
+            </a:r>
+          </a:p>
+          <a:p>
+            <a:r>
+              <a:t>- Pane: "a real terminal."</a:t>
             </a:r>
           </a:p>
           <a:p/>
           <a:p>
             <a:r>
-              <a:t>This is the shoulder tap agents never gave me.</a:t>
+              <a:t>If you know tmux, you already have most of this model. The difference is what Herdr knows about what's running in each pane.</a:t>
             </a:r>
           </a:p>
           <a:p/>
           <a:p>
             <a:r>
-              <a:t>Tip: run `herdr integration install claude` (or codex, copilot, opencode…) so the agent reports its own lifecycle through a hook instead of Herdr inferring it from the screen. `herdr integration status` shows what's wired.</a:t>
-            </a:r>
-          </a:p>
-          <a:p/>
-          <a:p>
-            <a:r>
-              <a:t>Refs:</a:t>
-            </a:r>
-          </a:p>
-          <a:p>
-            <a:r>
-              <a:t>- https://herdr.dev/docs/concepts/</a:t>
-            </a:r>
-          </a:p>
-          <a:p>
-            <a:r>
-              <a:t>- https://herdr.dev/docs/agents/</a:t>
+              <a:t>Ref: https://herdr.dev/docs/concepts/</a:t>
             </a:r>
           </a:p>
         </p:txBody>
@@ -2579,25 +2673,61 @@
           <a:lstStyle/>
           <a:p>
             <a:r>
-              <a:t>Rule one. Every folder I'm actively working in gets a space, named after the folder. Today that's about ten: interlinedlist plus its iOS, macOS, Windows, and Android siblings, an architecture migration, a couple of other projects, and this repo.</a:t>
+              <a:t>The sidebar. Spaces up top, every agent across every space listed below with a state dot.</a:t>
             </a:r>
           </a:p>
           <a:p/>
           <a:p>
             <a:r>
-              <a:t>Why folders? Because an agent's working directory is the edge of its universe. The space draws the same boundary the agent already lives in, and makes it visible to me.</a:t>
+              <a:t>- Blocked: needs input, approval, or a decision. This is the one you care about.</a:t>
+            </a:r>
+          </a:p>
+          <a:p>
+            <a:r>
+              <a:t>- Working: chewing.</a:t>
+            </a:r>
+          </a:p>
+          <a:p>
+            <a:r>
+              <a:t>- Done: finished, and you haven't looked yet.</a:t>
+            </a:r>
+          </a:p>
+          <a:p>
+            <a:r>
+              <a:t>- Idle: finished, and you have looked.</a:t>
+            </a:r>
+          </a:p>
+          <a:p>
+            <a:r>
+              <a:t>- Unknown: Herdr can't tell, usually a plain shell.</a:t>
             </a:r>
           </a:p>
           <a:p/>
           <a:p>
             <a:r>
-              <a:t>There's no 'misc' space. Misc is where context goes to die.</a:t>
+              <a:t>This is the shoulder tap agents never gave me.</a:t>
             </a:r>
           </a:p>
           <a:p/>
           <a:p>
             <a:r>
-              <a:t>My config even sorts the agent list by space: agent_panel_sort = "spaces".</a:t>
+              <a:t>Tip: run `herdr integration install claude` (or codex, copilot, opencode…) so the agent reports its own lifecycle through a hook instead of Herdr inferring it from the screen. `herdr integration status` shows what's wired.</a:t>
+            </a:r>
+          </a:p>
+          <a:p/>
+          <a:p>
+            <a:r>
+              <a:t>Refs:</a:t>
+            </a:r>
+          </a:p>
+          <a:p>
+            <a:r>
+              <a:t>- https://herdr.dev/docs/concepts/</a:t>
+            </a:r>
+          </a:p>
+          <a:p>
+            <a:r>
+              <a:t>- https://herdr.dev/docs/agents/</a:t>
             </a:r>
           </a:p>
         </p:txBody>
@@ -2667,30 +2797,25 @@
           <a:lstStyle/>
           <a:p>
             <a:r>
-              <a:t>A second space, transit-tracker, with its own implementation tab. Different folder, different agent, different world.</a:t>
+              <a:t>Rule one. Every folder I'm actively working in gets a space, named after the folder. Today that's about ten: interlinedlist plus its iOS, macOS, Windows, and Android siblings, an architecture migration, a couple of other projects, and this repo.</a:t>
             </a:r>
           </a:p>
           <a:p/>
           <a:p>
             <a:r>
-              <a:t>The sidebar is a direct readout of my working memory. If a folder isn't in it, I'm not working on it. When I'm done with a folder, the space goes away.</a:t>
+              <a:t>Why folders? Because an agent's working directory is the edge of its universe. The space draws the same boundary the agent already lives in, and makes it visible to me.</a:t>
             </a:r>
           </a:p>
           <a:p/>
           <a:p>
             <a:r>
-              <a:t>This is mostly for my own mental organization. The agents don't care what the sidebar looks like. I do.</a:t>
+              <a:t>There's no 'misc' space. Misc is where context goes to die.</a:t>
             </a:r>
           </a:p>
           <a:p/>
           <a:p>
             <a:r>
-              <a:t>Related: when two agents need the same repo at once, each gets a git worktree, which is just another folder, so another space. `herdr worktree create` does it directly.</a:t>
-            </a:r>
-          </a:p>
-          <a:p>
-            <a:r>
-              <a:t>Ref: https://compositecode.blog/2026/08/19/worktrees/</a:t>
+              <a:t>My config even sorts the agent list by space: agent_panel_sort = "spaces".</a:t>
             </a:r>
           </a:p>
         </p:txBody>
@@ -2760,41 +2885,30 @@
           <a:lstStyle/>
           <a:p>
             <a:r>
-              <a:t>Rule two. Tabs aren't 'more room.' Tabs are modes, and each one is a different verb.</a:t>
+              <a:t>A second space, transit-tracker, with its own implementation tab. Different folder, different agent, different world.</a:t>
             </a:r>
           </a:p>
           <a:p/>
           <a:p>
             <a:r>
-              <a:t>- domain-modeling: the agent thinks and doesn't type. Plan mode. Glossary and domain notes open beside it.</a:t>
-            </a:r>
-          </a:p>
-          <a:p>
-            <a:r>
-              <a:t>- implementation: the agent changes code inside an explicit scope, after an approved plan.</a:t>
-            </a:r>
-          </a:p>
-          <a:p>
-            <a:r>
-              <a:t>- pr-reviews: the agent reads the diff and reports findings. It doesn't fix.</a:t>
+              <a:t>The sidebar is a direct readout of my working memory. If a folder isn't in it, I'm not working on it. When I'm done with a folder, the space goes away.</a:t>
             </a:r>
           </a:p>
           <a:p/>
           <a:p>
             <a:r>
-              <a:t>What I'm designing against is verb drift: a reviewer that slides into rewriting the module. The tab is the line it has to cross, drawn on screen.</a:t>
+              <a:t>This is mostly for my own mental organization. The agents don't care what the sidebar looks like. I do.</a:t>
             </a:r>
           </a:p>
           <a:p/>
           <a:p>
             <a:r>
-              <a:t>It also switches my own hat. When I land on a tab called pr-reviews, I'm in review mode before I read a word.</a:t>
-            </a:r>
-          </a:p>
-          <a:p/>
-          <a:p>
-            <a:r>
-              <a:t>Ref: Ask, Plan, Confirm: https://compositecode.blog/2026/08/20/plan-then-build/</a:t>
+              <a:t>Related: when two agents need the same repo at once, each gets a git worktree, which is just another folder, so another space. `herdr worktree create` does it directly.</a:t>
+            </a:r>
+          </a:p>
+          <a:p>
+            <a:r>
+              <a:t>Ref: https://compositecode.blog/2026/08/19/worktrees/</a:t>
             </a:r>
           </a:p>
         </p:txBody>
@@ -6102,35 +6216,42 @@
           <a:lstStyle/>
           <a:p>
             <a:r>
-              <a:t>domain-modeling</a:t>
-            </a:r>
-          </a:p>
-        </p:txBody>
-      </p:sp>
-      <p:pic>
-        <p:nvPicPr>
-          <p:cNvPr id="3" name="Picture 2" descr="01-ultrawide-domain-modeling-tab.png"/>
-          <p:cNvPicPr>
-            <a:picLocks noChangeAspect="1"/>
-          </p:cNvPicPr>
-          <p:nvPr/>
-        </p:nvPicPr>
-        <p:blipFill>
-          <a:blip r:embed="rId2"/>
-          <a:stretch>
-            <a:fillRect/>
-          </a:stretch>
-        </p:blipFill>
-        <p:spPr>
-          <a:xfrm>
-            <a:off x="457200" y="2419462"/>
-            <a:ext cx="11277295" cy="3116674"/>
-          </a:xfrm>
-          <a:prstGeom prst="rect">
-            <a:avLst/>
-          </a:prstGeom>
-        </p:spPr>
-      </p:pic>
+              <a:t>One tab per kind of work</a:t>
+            </a:r>
+          </a:p>
+        </p:txBody>
+      </p:sp>
+      <p:sp>
+        <p:nvSpPr>
+          <p:cNvPr id="3" name="Content Placeholder 2"/>
+          <p:cNvSpPr>
+            <a:spLocks noGrp="1"/>
+          </p:cNvSpPr>
+          <p:nvPr>
+            <p:ph idx="1"/>
+          </p:nvPr>
+        </p:nvSpPr>
+        <p:spPr/>
+        <p:txBody>
+          <a:bodyPr/>
+          <a:lstStyle/>
+          <a:p>
+            <a:r>
+              <a:t>domain-modeling: think</a:t>
+            </a:r>
+          </a:p>
+          <a:p>
+            <a:r>
+              <a:t>implementation: change</a:t>
+            </a:r>
+          </a:p>
+          <a:p>
+            <a:r>
+              <a:t>pr-reviews: judge</a:t>
+            </a:r>
+          </a:p>
+        </p:txBody>
+      </p:sp>
     </p:spTree>
   </p:cSld>
   <p:clrMapOvr>
@@ -6165,14 +6286,14 @@
           <a:lstStyle/>
           <a:p>
             <a:r>
-              <a:t>implementation</a:t>
+              <a:t>domain-modeling</a:t>
             </a:r>
           </a:p>
         </p:txBody>
       </p:sp>
       <p:pic>
         <p:nvPicPr>
-          <p:cNvPr id="3" name="Picture 2" descr="02-ultrawide-implementation-tab.png"/>
+          <p:cNvPr id="3" name="Picture 2" descr="01-ultrawide-domain-modeling-tab.png"/>
           <p:cNvPicPr>
             <a:picLocks noChangeAspect="1"/>
           </p:cNvPicPr>
@@ -6228,14 +6349,14 @@
           <a:lstStyle/>
           <a:p>
             <a:r>
-              <a:t>pr-reviews</a:t>
+              <a:t>implementation</a:t>
             </a:r>
           </a:p>
         </p:txBody>
       </p:sp>
       <p:pic>
         <p:nvPicPr>
-          <p:cNvPr id="3" name="Picture 2" descr="04-ultrawide-pr-reviews-tab.png"/>
+          <p:cNvPr id="3" name="Picture 2" descr="02-ultrawide-implementation-tab.png"/>
           <p:cNvPicPr>
             <a:picLocks noChangeAspect="1"/>
           </p:cNvPicPr>
@@ -6291,16 +6412,35 @@
           <a:lstStyle/>
           <a:p>
             <a:r>
-              <a:t>Tall for agents.</a:t>
-            </a:r>
-          </a:p>
-          <a:p>
-            <a:r>
-              <a:t>Short for shells.</a:t>
-            </a:r>
-          </a:p>
-        </p:txBody>
-      </p:sp>
+              <a:t>pr-reviews</a:t>
+            </a:r>
+          </a:p>
+        </p:txBody>
+      </p:sp>
+      <p:pic>
+        <p:nvPicPr>
+          <p:cNvPr id="3" name="Picture 2" descr="04-ultrawide-pr-reviews-tab.png"/>
+          <p:cNvPicPr>
+            <a:picLocks noChangeAspect="1"/>
+          </p:cNvPicPr>
+          <p:nvPr/>
+        </p:nvPicPr>
+        <p:blipFill>
+          <a:blip r:embed="rId2"/>
+          <a:stretch>
+            <a:fillRect/>
+          </a:stretch>
+        </p:blipFill>
+        <p:spPr>
+          <a:xfrm>
+            <a:off x="457200" y="2419462"/>
+            <a:ext cx="11277295" cy="3116674"/>
+          </a:xfrm>
+          <a:prstGeom prst="rect">
+            <a:avLst/>
+          </a:prstGeom>
+        </p:spPr>
+      </p:pic>
     </p:spTree>
   </p:cSld>
   <p:clrMapOvr>
@@ -6335,28 +6475,12 @@
           <a:lstStyle/>
           <a:p>
             <a:r>
-              <a:t>32:9</a:t>
-            </a:r>
-          </a:p>
-        </p:txBody>
-      </p:sp>
-      <p:sp>
-        <p:nvSpPr>
-          <p:cNvPr id="3" name="Text Placeholder 2"/>
-          <p:cNvSpPr>
-            <a:spLocks noGrp="1"/>
-          </p:cNvSpPr>
-          <p:nvPr>
-            <p:ph type="body" idx="1"/>
-          </p:nvPr>
-        </p:nvSpPr>
-        <p:spPr/>
-        <p:txBody>
-          <a:bodyPr/>
-          <a:lstStyle/>
-          <a:p>
-            <a:r>
-              <a:t>5120 × 1440</a:t>
+              <a:t>Tall for agents.</a:t>
+            </a:r>
+          </a:p>
+          <a:p>
+            <a:r>
+              <a:t>Short for shells.</a:t>
             </a:r>
           </a:p>
         </p:txBody>
@@ -6370,6 +6494,66 @@
 </file>
 
 <file path=ppt/slides/slide15.xml><?xml version="1.0" encoding="utf-8"?>
+<p:sld xmlns:a="http://schemas.openxmlformats.org/drawingml/2006/main" xmlns:p="http://schemas.openxmlformats.org/presentationml/2006/main" xmlns:r="http://schemas.openxmlformats.org/officeDocument/2006/relationships">
+  <p:cSld>
+    <p:spTree>
+      <p:nvGrpSpPr>
+        <p:cNvPr id="1" name=""/>
+        <p:cNvGrpSpPr/>
+        <p:nvPr/>
+      </p:nvGrpSpPr>
+      <p:grpSpPr/>
+      <p:sp>
+        <p:nvSpPr>
+          <p:cNvPr id="2" name="Title 1"/>
+          <p:cNvSpPr>
+            <a:spLocks noGrp="1"/>
+          </p:cNvSpPr>
+          <p:nvPr>
+            <p:ph type="title"/>
+          </p:nvPr>
+        </p:nvSpPr>
+        <p:spPr/>
+        <p:txBody>
+          <a:bodyPr/>
+          <a:lstStyle/>
+          <a:p>
+            <a:r>
+              <a:t>32:9</a:t>
+            </a:r>
+          </a:p>
+        </p:txBody>
+      </p:sp>
+      <p:sp>
+        <p:nvSpPr>
+          <p:cNvPr id="3" name="Text Placeholder 2"/>
+          <p:cNvSpPr>
+            <a:spLocks noGrp="1"/>
+          </p:cNvSpPr>
+          <p:nvPr>
+            <p:ph type="body" idx="1"/>
+          </p:nvPr>
+        </p:nvSpPr>
+        <p:spPr/>
+        <p:txBody>
+          <a:bodyPr/>
+          <a:lstStyle/>
+          <a:p>
+            <a:r>
+              <a:t>5120 × 1440</a:t>
+            </a:r>
+          </a:p>
+        </p:txBody>
+      </p:sp>
+    </p:spTree>
+  </p:cSld>
+  <p:clrMapOvr>
+    <a:masterClrMapping/>
+  </p:clrMapOvr>
+</p:sld>
+</file>
+
+<file path=ppt/slides/slide16.xml><?xml version="1.0" encoding="utf-8"?>
 <p:sld xmlns:a="http://schemas.openxmlformats.org/drawingml/2006/main" xmlns:p="http://schemas.openxmlformats.org/presentationml/2006/main" xmlns:r="http://schemas.openxmlformats.org/officeDocument/2006/relationships">
   <p:cSld>
     <p:spTree>
@@ -6432,7 +6616,7 @@
 </p:sld>
 </file>
 
-<file path=ppt/slides/slide16.xml><?xml version="1.0" encoding="utf-8"?>
+<file path=ppt/slides/slide17.xml><?xml version="1.0" encoding="utf-8"?>
 <p:sld xmlns:a="http://schemas.openxmlformats.org/drawingml/2006/main" xmlns:p="http://schemas.openxmlformats.org/presentationml/2006/main" xmlns:r="http://schemas.openxmlformats.org/officeDocument/2006/relationships">
   <p:cSld>
     <p:spTree>
@@ -6495,7 +6679,7 @@
 </p:sld>
 </file>
 
-<file path=ppt/slides/slide17.xml><?xml version="1.0" encoding="utf-8"?>
+<file path=ppt/slides/slide18.xml><?xml version="1.0" encoding="utf-8"?>
 <p:sld xmlns:a="http://schemas.openxmlformats.org/drawingml/2006/main" xmlns:p="http://schemas.openxmlformats.org/presentationml/2006/main" xmlns:r="http://schemas.openxmlformats.org/officeDocument/2006/relationships">
   <p:cSld>
     <p:spTree>
@@ -6534,7 +6718,7 @@
 </p:sld>
 </file>
 
-<file path=ppt/slides/slide18.xml><?xml version="1.0" encoding="utf-8"?>
+<file path=ppt/slides/slide19.xml><?xml version="1.0" encoding="utf-8"?>
 <p:sld xmlns:a="http://schemas.openxmlformats.org/drawingml/2006/main" xmlns:p="http://schemas.openxmlformats.org/presentationml/2006/main" xmlns:r="http://schemas.openxmlformats.org/officeDocument/2006/relationships">
   <p:cSld>
     <p:spTree>
@@ -6597,7 +6781,51 @@
 </p:sld>
 </file>
 
-<file path=ppt/slides/slide19.xml><?xml version="1.0" encoding="utf-8"?>
+<file path=ppt/slides/slide2.xml><?xml version="1.0" encoding="utf-8"?>
+<p:sld xmlns:a="http://schemas.openxmlformats.org/drawingml/2006/main" xmlns:p="http://schemas.openxmlformats.org/presentationml/2006/main" xmlns:r="http://schemas.openxmlformats.org/officeDocument/2006/relationships">
+  <p:cSld>
+    <p:spTree>
+      <p:nvGrpSpPr>
+        <p:cNvPr id="1" name=""/>
+        <p:cNvGrpSpPr/>
+        <p:nvPr/>
+      </p:nvGrpSpPr>
+      <p:grpSpPr/>
+      <p:sp>
+        <p:nvSpPr>
+          <p:cNvPr id="2" name="Title 1"/>
+          <p:cNvSpPr>
+            <a:spLocks noGrp="1"/>
+          </p:cNvSpPr>
+          <p:nvPr>
+            <p:ph type="title"/>
+          </p:nvPr>
+        </p:nvSpPr>
+        <p:spPr/>
+        <p:txBody>
+          <a:bodyPr/>
+          <a:lstStyle/>
+          <a:p>
+            <a:r>
+              <a:t>One agent is a tool.</a:t>
+            </a:r>
+          </a:p>
+          <a:p>
+            <a:r>
+              <a:t>Six is a zoo.</a:t>
+            </a:r>
+          </a:p>
+        </p:txBody>
+      </p:sp>
+    </p:spTree>
+  </p:cSld>
+  <p:clrMapOvr>
+    <a:masterClrMapping/>
+  </p:clrMapOvr>
+</p:sld>
+</file>
+
+<file path=ppt/slides/slide20.xml><?xml version="1.0" encoding="utf-8"?>
 <p:sld xmlns:a="http://schemas.openxmlformats.org/drawingml/2006/main" xmlns:p="http://schemas.openxmlformats.org/presentationml/2006/main" xmlns:r="http://schemas.openxmlformats.org/officeDocument/2006/relationships">
   <p:cSld>
     <p:spTree>
@@ -6660,51 +6888,7 @@
 </p:sld>
 </file>
 
-<file path=ppt/slides/slide2.xml><?xml version="1.0" encoding="utf-8"?>
-<p:sld xmlns:a="http://schemas.openxmlformats.org/drawingml/2006/main" xmlns:p="http://schemas.openxmlformats.org/presentationml/2006/main" xmlns:r="http://schemas.openxmlformats.org/officeDocument/2006/relationships">
-  <p:cSld>
-    <p:spTree>
-      <p:nvGrpSpPr>
-        <p:cNvPr id="1" name=""/>
-        <p:cNvGrpSpPr/>
-        <p:nvPr/>
-      </p:nvGrpSpPr>
-      <p:grpSpPr/>
-      <p:sp>
-        <p:nvSpPr>
-          <p:cNvPr id="2" name="Title 1"/>
-          <p:cNvSpPr>
-            <a:spLocks noGrp="1"/>
-          </p:cNvSpPr>
-          <p:nvPr>
-            <p:ph type="title"/>
-          </p:nvPr>
-        </p:nvSpPr>
-        <p:spPr/>
-        <p:txBody>
-          <a:bodyPr/>
-          <a:lstStyle/>
-          <a:p>
-            <a:r>
-              <a:t>One agent is a tool.</a:t>
-            </a:r>
-          </a:p>
-          <a:p>
-            <a:r>
-              <a:t>Six is a zoo.</a:t>
-            </a:r>
-          </a:p>
-        </p:txBody>
-      </p:sp>
-    </p:spTree>
-  </p:cSld>
-  <p:clrMapOvr>
-    <a:masterClrMapping/>
-  </p:clrMapOvr>
-</p:sld>
-</file>
-
-<file path=ppt/slides/slide20.xml><?xml version="1.0" encoding="utf-8"?>
+<file path=ppt/slides/slide21.xml><?xml version="1.0" encoding="utf-8"?>
 <p:sld xmlns:a="http://schemas.openxmlformats.org/drawingml/2006/main" xmlns:p="http://schemas.openxmlformats.org/presentationml/2006/main" xmlns:r="http://schemas.openxmlformats.org/officeDocument/2006/relationships">
   <p:cSld>
     <p:spTree>
@@ -6767,91 +6951,6 @@
 </p:sld>
 </file>
 
-<file path=ppt/slides/slide21.xml><?xml version="1.0" encoding="utf-8"?>
-<p:sld xmlns:a="http://schemas.openxmlformats.org/drawingml/2006/main" xmlns:p="http://schemas.openxmlformats.org/presentationml/2006/main" xmlns:r="http://schemas.openxmlformats.org/officeDocument/2006/relationships">
-  <p:cSld>
-    <p:spTree>
-      <p:nvGrpSpPr>
-        <p:cNvPr id="1" name=""/>
-        <p:cNvGrpSpPr/>
-        <p:nvPr/>
-      </p:nvGrpSpPr>
-      <p:grpSpPr/>
-      <p:sp>
-        <p:nvSpPr>
-          <p:cNvPr id="2" name="Title 1"/>
-          <p:cNvSpPr>
-            <a:spLocks noGrp="1"/>
-          </p:cNvSpPr>
-          <p:nvPr>
-            <p:ph type="title"/>
-          </p:nvPr>
-        </p:nvSpPr>
-        <p:spPr/>
-        <p:txBody>
-          <a:bodyPr/>
-          <a:lstStyle/>
-          <a:p>
-            <a:r>
-              <a:t>The prompt shape</a:t>
-            </a:r>
-          </a:p>
-        </p:txBody>
-      </p:sp>
-      <p:sp>
-        <p:nvSpPr>
-          <p:cNvPr id="3" name="Content Placeholder 2"/>
-          <p:cNvSpPr>
-            <a:spLocks noGrp="1"/>
-          </p:cNvSpPr>
-          <p:nvPr>
-            <p:ph idx="1"/>
-          </p:nvPr>
-        </p:nvSpPr>
-        <p:spPr/>
-        <p:txBody>
-          <a:bodyPr/>
-          <a:lstStyle/>
-          <a:p>
-            <a:r>
-              <a:t>Scope</a:t>
-            </a:r>
-          </a:p>
-          <a:p>
-            <a:r>
-              <a:t>Context and vocabulary</a:t>
-            </a:r>
-          </a:p>
-          <a:p>
-            <a:r>
-              <a:t>One verb, one job</a:t>
-            </a:r>
-          </a:p>
-          <a:p>
-            <a:r>
-              <a:t>Constraints as numbers</a:t>
-            </a:r>
-          </a:p>
-          <a:p>
-            <a:r>
-              <a:t>Output shape</a:t>
-            </a:r>
-          </a:p>
-          <a:p>
-            <a:r>
-              <a:t>If blocked, stop and ask</a:t>
-            </a:r>
-          </a:p>
-        </p:txBody>
-      </p:sp>
-    </p:spTree>
-  </p:cSld>
-  <p:clrMapOvr>
-    <a:masterClrMapping/>
-  </p:clrMapOvr>
-</p:sld>
-</file>
-
 <file path=ppt/slides/slide22.xml><?xml version="1.0" encoding="utf-8"?>
 <p:sld xmlns:a="http://schemas.openxmlformats.org/drawingml/2006/main" xmlns:p="http://schemas.openxmlformats.org/presentationml/2006/main" xmlns:r="http://schemas.openxmlformats.org/officeDocument/2006/relationships">
   <p:cSld>
@@ -6878,7 +6977,53 @@
           <a:lstStyle/>
           <a:p>
             <a:r>
-              <a:t>Ask. Plan. Confirm.</a:t>
+              <a:t>The prompt shape</a:t>
+            </a:r>
+          </a:p>
+        </p:txBody>
+      </p:sp>
+      <p:sp>
+        <p:nvSpPr>
+          <p:cNvPr id="3" name="Content Placeholder 2"/>
+          <p:cNvSpPr>
+            <a:spLocks noGrp="1"/>
+          </p:cNvSpPr>
+          <p:nvPr>
+            <p:ph idx="1"/>
+          </p:nvPr>
+        </p:nvSpPr>
+        <p:spPr/>
+        <p:txBody>
+          <a:bodyPr/>
+          <a:lstStyle/>
+          <a:p>
+            <a:r>
+              <a:t>Scope</a:t>
+            </a:r>
+          </a:p>
+          <a:p>
+            <a:r>
+              <a:t>Context and vocabulary</a:t>
+            </a:r>
+          </a:p>
+          <a:p>
+            <a:r>
+              <a:t>One verb, one job</a:t>
+            </a:r>
+          </a:p>
+          <a:p>
+            <a:r>
+              <a:t>Constraints as numbers</a:t>
+            </a:r>
+          </a:p>
+          <a:p>
+            <a:r>
+              <a:t>Output shape</a:t>
+            </a:r>
+          </a:p>
+          <a:p>
+            <a:r>
+              <a:t>If blocked, stop and ask</a:t>
             </a:r>
           </a:p>
         </p:txBody>
@@ -6917,38 +7062,7 @@
           <a:lstStyle/>
           <a:p>
             <a:r>
-              <a:t>Try it</a:t>
-            </a:r>
-          </a:p>
-        </p:txBody>
-      </p:sp>
-      <p:sp>
-        <p:nvSpPr>
-          <p:cNvPr id="3" name="Content Placeholder 2"/>
-          <p:cNvSpPr>
-            <a:spLocks noGrp="1"/>
-          </p:cNvSpPr>
-          <p:nvPr>
-            <p:ph idx="1"/>
-          </p:nvPr>
-        </p:nvSpPr>
-        <p:spPr/>
-        <p:txBody>
-          <a:bodyPr/>
-          <a:lstStyle/>
-          <a:p>
-            <a:r>
-              <a:t>brew install herdr</a:t>
-            </a:r>
-          </a:p>
-          <a:p>
-            <a:r>
-              <a:t>herdr</a:t>
-            </a:r>
-          </a:p>
-          <a:p>
-            <a:r>
-              <a:t>ctrl+b  ?</a:t>
+              <a:t>Ask. Plan. Confirm.</a:t>
             </a:r>
           </a:p>
         </p:txBody>
@@ -6962,6 +7076,76 @@
 </file>
 
 <file path=ppt/slides/slide24.xml><?xml version="1.0" encoding="utf-8"?>
+<p:sld xmlns:a="http://schemas.openxmlformats.org/drawingml/2006/main" xmlns:p="http://schemas.openxmlformats.org/presentationml/2006/main" xmlns:r="http://schemas.openxmlformats.org/officeDocument/2006/relationships">
+  <p:cSld>
+    <p:spTree>
+      <p:nvGrpSpPr>
+        <p:cNvPr id="1" name=""/>
+        <p:cNvGrpSpPr/>
+        <p:nvPr/>
+      </p:nvGrpSpPr>
+      <p:grpSpPr/>
+      <p:sp>
+        <p:nvSpPr>
+          <p:cNvPr id="2" name="Title 1"/>
+          <p:cNvSpPr>
+            <a:spLocks noGrp="1"/>
+          </p:cNvSpPr>
+          <p:nvPr>
+            <p:ph type="title"/>
+          </p:nvPr>
+        </p:nvSpPr>
+        <p:spPr/>
+        <p:txBody>
+          <a:bodyPr/>
+          <a:lstStyle/>
+          <a:p>
+            <a:r>
+              <a:t>Try it</a:t>
+            </a:r>
+          </a:p>
+        </p:txBody>
+      </p:sp>
+      <p:sp>
+        <p:nvSpPr>
+          <p:cNvPr id="3" name="Content Placeholder 2"/>
+          <p:cNvSpPr>
+            <a:spLocks noGrp="1"/>
+          </p:cNvSpPr>
+          <p:nvPr>
+            <p:ph idx="1"/>
+          </p:nvPr>
+        </p:nvSpPr>
+        <p:spPr/>
+        <p:txBody>
+          <a:bodyPr/>
+          <a:lstStyle/>
+          <a:p>
+            <a:r>
+              <a:t>brew install herdr</a:t>
+            </a:r>
+          </a:p>
+          <a:p>
+            <a:r>
+              <a:t>herdr</a:t>
+            </a:r>
+          </a:p>
+          <a:p>
+            <a:r>
+              <a:t>ctrl+b  ?</a:t>
+            </a:r>
+          </a:p>
+        </p:txBody>
+      </p:sp>
+    </p:spTree>
+  </p:cSld>
+  <p:clrMapOvr>
+    <a:masterClrMapping/>
+  </p:clrMapOvr>
+</p:sld>
+</file>
+
+<file path=ppt/slides/slide25.xml><?xml version="1.0" encoding="utf-8"?>
 <p:sld xmlns:a="http://schemas.openxmlformats.org/drawingml/2006/main" xmlns:p="http://schemas.openxmlformats.org/presentationml/2006/main" xmlns:r="http://schemas.openxmlformats.org/officeDocument/2006/relationships">
   <p:cSld>
     <p:spTree>
@@ -7216,7 +7400,43 @@
           <a:lstStyle/>
           <a:p>
             <a:r>
-              <a:t>Session › Space › Tab › Pane</a:t>
+              <a:t>Installs in one line</a:t>
+            </a:r>
+          </a:p>
+        </p:txBody>
+      </p:sp>
+      <p:sp>
+        <p:nvSpPr>
+          <p:cNvPr id="3" name="Content Placeholder 2"/>
+          <p:cNvSpPr>
+            <a:spLocks noGrp="1"/>
+          </p:cNvSpPr>
+          <p:nvPr>
+            <p:ph idx="1"/>
+          </p:nvPr>
+        </p:nvSpPr>
+        <p:spPr/>
+        <p:txBody>
+          <a:bodyPr/>
+          <a:lstStyle/>
+          <a:p>
+            <a:r>
+              <a:t>brew install herdr</a:t>
+            </a:r>
+          </a:p>
+          <a:p>
+            <a:r>
+              <a:t>curl -fsSL https://herdr.dev/install.sh | sh</a:t>
+            </a:r>
+          </a:p>
+          <a:p>
+            <a:r>
+              <a:t>herdr</a:t>
+            </a:r>
+          </a:p>
+          <a:p>
+            <a:r>
+              <a:t>herdr integration install claude</a:t>
             </a:r>
           </a:p>
         </p:txBody>
@@ -7230,6 +7450,45 @@
 </file>
 
 <file path=ppt/slides/slide6.xml><?xml version="1.0" encoding="utf-8"?>
+<p:sld xmlns:a="http://schemas.openxmlformats.org/drawingml/2006/main" xmlns:p="http://schemas.openxmlformats.org/presentationml/2006/main" xmlns:r="http://schemas.openxmlformats.org/officeDocument/2006/relationships">
+  <p:cSld>
+    <p:spTree>
+      <p:nvGrpSpPr>
+        <p:cNvPr id="1" name=""/>
+        <p:cNvGrpSpPr/>
+        <p:nvPr/>
+      </p:nvGrpSpPr>
+      <p:grpSpPr/>
+      <p:sp>
+        <p:nvSpPr>
+          <p:cNvPr id="2" name="Title 1"/>
+          <p:cNvSpPr>
+            <a:spLocks noGrp="1"/>
+          </p:cNvSpPr>
+          <p:nvPr>
+            <p:ph type="title"/>
+          </p:nvPr>
+        </p:nvSpPr>
+        <p:spPr/>
+        <p:txBody>
+          <a:bodyPr/>
+          <a:lstStyle/>
+          <a:p>
+            <a:r>
+              <a:t>Session › Space › Tab › Pane</a:t>
+            </a:r>
+          </a:p>
+        </p:txBody>
+      </p:sp>
+    </p:spTree>
+  </p:cSld>
+  <p:clrMapOvr>
+    <a:masterClrMapping/>
+  </p:clrMapOvr>
+</p:sld>
+</file>
+
+<file path=ppt/slides/slide7.xml><?xml version="1.0" encoding="utf-8"?>
 <p:sld xmlns:a="http://schemas.openxmlformats.org/drawingml/2006/main" xmlns:p="http://schemas.openxmlformats.org/presentationml/2006/main" xmlns:r="http://schemas.openxmlformats.org/officeDocument/2006/relationships">
   <p:cSld>
     <p:spTree>
@@ -7297,7 +7556,7 @@
 </p:sld>
 </file>
 
-<file path=ppt/slides/slide7.xml><?xml version="1.0" encoding="utf-8"?>
+<file path=ppt/slides/slide8.xml><?xml version="1.0" encoding="utf-8"?>
 <p:sld xmlns:a="http://schemas.openxmlformats.org/drawingml/2006/main" xmlns:p="http://schemas.openxmlformats.org/presentationml/2006/main" xmlns:r="http://schemas.openxmlformats.org/officeDocument/2006/relationships">
   <p:cSld>
     <p:spTree>
@@ -7336,7 +7595,7 @@
 </p:sld>
 </file>
 
-<file path=ppt/slides/slide8.xml><?xml version="1.0" encoding="utf-8"?>
+<file path=ppt/slides/slide9.xml><?xml version="1.0" encoding="utf-8"?>
 <p:sld xmlns:a="http://schemas.openxmlformats.org/drawingml/2006/main" xmlns:p="http://schemas.openxmlformats.org/presentationml/2006/main" xmlns:r="http://schemas.openxmlformats.org/officeDocument/2006/relationships">
   <p:cSld>
     <p:spTree>
@@ -7391,76 +7650,6 @@
           </a:prstGeom>
         </p:spPr>
       </p:pic>
-    </p:spTree>
-  </p:cSld>
-  <p:clrMapOvr>
-    <a:masterClrMapping/>
-  </p:clrMapOvr>
-</p:sld>
-</file>
-
-<file path=ppt/slides/slide9.xml><?xml version="1.0" encoding="utf-8"?>
-<p:sld xmlns:a="http://schemas.openxmlformats.org/drawingml/2006/main" xmlns:p="http://schemas.openxmlformats.org/presentationml/2006/main" xmlns:r="http://schemas.openxmlformats.org/officeDocument/2006/relationships">
-  <p:cSld>
-    <p:spTree>
-      <p:nvGrpSpPr>
-        <p:cNvPr id="1" name=""/>
-        <p:cNvGrpSpPr/>
-        <p:nvPr/>
-      </p:nvGrpSpPr>
-      <p:grpSpPr/>
-      <p:sp>
-        <p:nvSpPr>
-          <p:cNvPr id="2" name="Title 1"/>
-          <p:cNvSpPr>
-            <a:spLocks noGrp="1"/>
-          </p:cNvSpPr>
-          <p:nvPr>
-            <p:ph type="title"/>
-          </p:nvPr>
-        </p:nvSpPr>
-        <p:spPr/>
-        <p:txBody>
-          <a:bodyPr/>
-          <a:lstStyle/>
-          <a:p>
-            <a:r>
-              <a:t>One tab per kind of work</a:t>
-            </a:r>
-          </a:p>
-        </p:txBody>
-      </p:sp>
-      <p:sp>
-        <p:nvSpPr>
-          <p:cNvPr id="3" name="Content Placeholder 2"/>
-          <p:cNvSpPr>
-            <a:spLocks noGrp="1"/>
-          </p:cNvSpPr>
-          <p:nvPr>
-            <p:ph idx="1"/>
-          </p:nvPr>
-        </p:nvSpPr>
-        <p:spPr/>
-        <p:txBody>
-          <a:bodyPr/>
-          <a:lstStyle/>
-          <a:p>
-            <a:r>
-              <a:t>domain-modeling: think</a:t>
-            </a:r>
-          </a:p>
-          <a:p>
-            <a:r>
-              <a:t>implementation: change</a:t>
-            </a:r>
-          </a:p>
-          <a:p>
-            <a:r>
-              <a:t>pr-reviews: judge</a:t>
-            </a:r>
-          </a:p>
-        </p:txBody>
-      </p:sp>
     </p:spTree>
   </p:cSld>
   <p:clrMapOvr>

</xml_diff>